<commit_message>
Add five HIV/ART curves; reframe around measured dropout-hazard shape
Digitize three further published HIV/ART retention curves (Maputo ATT/BTT
PMC13037074, Malawi pre-intervention PMC13191892, Gambella youth PMC12903592)
via scripts/digitize.py and add all four series to the fit/figure/manuscript
pipeline (no hardcoded values; make regenerates everything).

Expanded evidence shows hazard-shape heterogeneity WITHIN HIV as well as within
TB (k 0.44-1.86; 4 IFR, 4 DFR), so the earlier 'comparators uniformly DFR'
framing no longer holds. Manuscript rewritten around: dropout timing must be
measured (Weibull shape), not assumed/intuited; this also makes intervention
effects verifiable; current open data too sparse for definitive patterns.

Co-Authored-By: Tatsuki Onishi <bougtoir@gmail.com>
</commit_message>
<xml_diff>
--- a/weibull-clinical-dropout/reanalysis_real/manuscript/figures_editable_en.pptx
+++ b/weibull-clinical-dropout/reanalysis_real/manuscript/figures_editable_en.pptx
@@ -3112,7 +3112,7 @@
           <a:p>
             <a:r>
               <a:rPr sz="2000"/>
-              <a:t>Figure 1. Weibull fits to digitized treatment-dropout curves (TB vs comparators)</a:t>
+              <a:t>Figure 1. Weibull fits to digitized treatment-dropout curves (TB and HIV cohorts)</a:t>
             </a:r>
           </a:p>
         </p:txBody>
@@ -3133,8 +3133,8 @@
         </p:blipFill>
         <p:spPr>
           <a:xfrm>
-            <a:off x="1280160" y="1005840"/>
-            <a:ext cx="9601200" cy="7419109"/>
+            <a:off x="3566160" y="914400"/>
+            <a:ext cx="4157472" cy="5669280"/>
           </a:xfrm>
           <a:prstGeom prst="rect">
             <a:avLst/>
@@ -3149,8 +3149,8 @@
         </p:nvSpPr>
         <p:spPr>
           <a:xfrm>
-            <a:off x="457200" y="6126480"/>
-            <a:ext cx="11247120" cy="640080"/>
+            <a:off x="457200" y="6537960"/>
+            <a:ext cx="11247120" cy="320040"/>
           </a:xfrm>
           <a:prstGeom prst="rect">
             <a:avLst/>
@@ -3165,7 +3165,7 @@
           <a:p>
             <a:r>
               <a:rPr sz="1200"/>
-              <a:t>TB splits between IFR (Ethiopia) and DFR (China); HIV/ART and antipsychotic comparators are DFR. Values: results/weibull_fits.csv.</a:t>
+              <a:t>Hazard shape (k) is heterogeneous within TB and within HIV alike (both IFR and DFR appear in each). Values: results/weibull_fits.csv.</a:t>
             </a:r>
           </a:p>
         </p:txBody>

</xml_diff>